<commit_message>
Video 1: fix drift count (6 inputs), report artefact always kept, timeline/facts, rebalanced knowledge check; ignore .fuse_hidden
</commit_message>
<xml_diff>
--- a/2026-27/S09/MLOps_S09_Video1_Monitoring_Metrics_in_Depth.pptx
+++ b/2026-27/S09/MLOps_S09_Video1_Monitoring_Metrics_in_Depth.pptx
@@ -486,7 +486,7 @@
             <a:r>
               <a:rPr lang="en-US" dirty="0"/>
               <a:t>RECORDING SCRIPT · minute 20:00
-Because precision and recall depend on the threshold, we want one number that does not: the AUC, the area under the ROC curve. The intuition without the curve: take one churner and one stayer at random; the AUC is the probability the model gave the churner the higher score. 0.5 is a coin toss, 1.0 perfect ranking, 0.8 good for churn; the fraud model in Session 3 had about 0.87. For: comparing versions regardless of the threshold, tracking separation over time. Not for: performance at your threshold, or whether "70%" means 70%.
+Because precision and recall depend on the threshold, we want one number that does not: the AUC, the area under the ROC curve. The intuition without the curve: take one churner and one stayer at random; the AUC is the probability the model gave the churner the higher score. 0.5 is a coin toss, 1.0 perfect ranking, 0.8 good for churn; the churn model in the Session 3 demo scored about 0.87. For: comparing versions regardless of the threshold, tracking separation over time. Not for: performance at your threshold, or whether "70%" means 70%.
 That last question is calibration. Take all customers scored between 75% and 85%; if about 80% of them churned, the model is calibrated. If only 50% did, it is overconfident: rankings dressed as probabilities. Why it matters: people act on the number. A €50 discount to everyone "above 80%" wastes half the budget if 80% means 50%. Drift often breaks calibration before it breaks ranking: the order is still right, every score is too high. Measured with the calibration curve, bucket by bucket against the diagonal, and one number, the Brier score. By segment too. And, again, both need the truth to be computed.
 [Timing: 20:00–22:30]</a:t>
             </a:r>
@@ -760,7 +760,7 @@
             <a:r>
               <a:rPr lang="en-US" dirty="0"/>
               <a:t>RECORDING SCRIPT · minute 26:00
-Four ways the truth goes missing. First, late. The churn label is 30 days behind; the credit label a year. Your performance chart for October is drawn in December; the model may have been wrong for two months while the dashboard said "no data yet". The cost is time, and the response is segment one: the early warnings, and a dashboard that shows "pending" honestly instead of a flat line.
+Four ways the truth goes missing. First, late. The churn label is 30 days behind; the credit label a year. Your churn chart for October can only be drawn in November, and for credit a year later; the model may have been wrong for a whole month while the dashboard said "no data yet". The cost is time, and the response is segment one: the early warnings, and a dashboard that shows "pending" honestly instead of a flat line.
 Second, decoupled. The prediction is logged in one system, the outcome in another, with different keys, and nobody designed the join. Fraud predictions are keyed by transaction; chargebacks by card and date. Half the outcomes cannot be matched to the score that was given. The metric is computed on the half that matched, which is not a random half.
 Third, and this is the subtle one: partial, because the model's own decision hides the truth. IberBank blocks a transaction; you never learn whether it was fraud, because it never happened. The bank rejects a loan; you never learn whether the applicant would have paid. NorthRetail stocks 100 units and sells 100; true demand was maybe 150. This is the selective-labels problem: you only get the truth for the cases the model let through. Recall computed on that data is not recall: the false negatives you can see are only the ones that slipped past; the false positives are invisible, so the model looks better than it is, and it gets more confident about the very cases it never checks.
 Fourth, absent. The HR assistant answers a question; the employee reads it and closes the window. There is no outcome to arrive; the only truth is a judgement someone makes afterwards, and it exists only for the sample they judge.
@@ -853,7 +853,7 @@
             <a:r>
               <a:rPr lang="en-US" dirty="0"/>
               <a:t>RECORDING SCRIPT · minute 29:00
-Five practices; none is free, all are cheaper than finding out in December. One: proxies. Something you can measure now that moves with the truth: prediction drift; the business KPI; for fraud, the share of blocked customers who call to complain, which is a fast proxy for false positives; for the assistant, thumbs down and rephrasing. Proxies trigger investigation, never retraining on their own.
+Five practices; none is free, all are cheaper than finding out a month late. One: proxies. Something you can measure now that moves with the truth: prediction drift; the business KPI; for fraud, the share of blocked customers who call to complain, which is a fast proxy for false positives; for the assistant, thumbs down and rephrasing. Proxies trigger investigation, never retraining on their own.
 Two: design the join before go-live. Every prediction stored with an id, a timestamp and the model version, and an agreed key to the outcome system. This is a Session 3 habit with a Session 9 reason: when the truth arrives, it must find its prediction.
 Three: backfill and recompute. When labels land, recompute October's metrics into October's slot, by segment, and keep the "pending" label until then. A performance chart that shows a flat line for months with no labels is lying.
 Four: random samples let through. To learn what the model hides, take a small random share of blocked transactions, rejected applications or unstocked products and let them through, or review them by hand. IberBank lets one in two hundred flagged payments through; that is how it learns its false-positive rate. Expensive, and the only honest measurement of recall you will get; the cost is a business decision, and it is a fairness question too: whom does the model never learn about?
@@ -949,7 +949,7 @@
               <a:t>RECORDING SCRIPT · minute 31:00
 Segment four, short: the metrics IT already collects for every service, and where models add something. Latency: how long one prediction takes. Throughput: predictions per second. Error rate: the share of requests that fail: timeouts, crashes, inputs rejected. None of them needs the truth; all of them are available in real time.
 The trap is the average. A bank branch with one queue: the average wait is four minutes, but one customer in twenty waits twenty-five. The percentile shows them; the average hides them. p95 is the time within which 95% of requests are answered. The fraud model's "under 150 ms" must be p95 under 150 ms, or one card payment in twenty is slow. When you see a latency number, ask "which percentile?".
-Model-specific additions: the share of requests with missing or out-of-range features, the Session 3 data checks applied live; for batch models, whether the run finished on time: the churn list must exist before the retention team starts at six; a late batch is an outage. Cost per thousand predictions, next to accuracy, because a model 1% better and three times more expensive is a business decision. And freshness: last data snapshot, last retrain; NorthRetail ran six months on features silently empty since February; "share of features updated this week" would have shown it. End of segment four.
+Model-specific additions: the share of requests with missing or out-of-range features, the Session 3 data checks applied live; for batch models, whether the run finished on time: the churn list must exist before the retention team starts at six; a late batch is an outage. Cost per thousand predictions, next to accuracy, because a model 1% better and three times more expensive is a business decision. And freshness: last data snapshot, last retrain; NorthRetail ran four months, from February to June, on features silently empty; "share of features updated this week" would have shown it. End of segment four.
 [Timing: 31:00–34:00]</a:t>
             </a:r>
             <a:endParaRPr lang="en-US" dirty="0"/>
@@ -1222,7 +1222,7 @@
             <a:r>
               <a:rPr lang="en-US" dirty="0"/>
               <a:t>RECORDING SCRIPT · minute 39:00
-Four failure rates. Hallucination rate: the share of answers stating something not supported by the sources, or plainly false; a judge compares each claim with the retrieved passages, humans confirm a sample; for the HR assistant, an invented number of holiday days has a legal consequence; the Air Canada case in Session 10 cost a lawsuit. Toxicity, or HAP, hate, abuse and profanity: the share of inputs and outputs flagged by a classifier; both directions, because users provoke and models sometimes comply. PII: the share of inputs and outputs containing names, identifiers, salaries; the policy documents contain real examples and the assistant must not repeat them. Detectors are cheap enough to run on every request; the rates go on the dashboard with thresholds, and some thresholds are zero: any PII in an output is an incident, not a trend.
+Four failure rates. Hallucination rate: the share of answers stating something not supported by the sources, or plainly false; a judge compares each claim with the retrieved passages, humans confirm a sample; for the HR assistant, an invented number of holiday days has a legal consequence; in the Air Canada case you will meet in Session 10, a tribunal made the airline pay for what its chatbot had invented. Toxicity, or HAP, hate, abuse and profanity: the share of inputs and outputs flagged by a classifier; both directions, because users provoke and models sometimes comply. PII: the share of inputs and outputs containing names, identifiers, salaries; the policy documents contain real examples and the assistant must not repeat them. Detectors are cheap enough to run on every request; the rates go on the dashboard with thresholds, and some thresholds are zero: any PII in an output is an incident, not a trend.
 The fourth is specific to retrieval systems, and has two halves. Retrieval quality: did we find the right passages? On the golden set, hit rate; live, the share of questions where nothing relevant was found, which usually means the documents are missing something. Groundedness: was the answer built from what was retrieved? A judge checks claim by claim; correct but ungrounded is still a failure, because next time the memory will be wrong. When the policy changes and the documents are updated, groundedness tells you whether the assistant answers from the new policy or from memory.
 [Timing: 39:00–41:30]</a:t>
             </a:r>
@@ -1313,7 +1313,7 @@
             <a:r>
               <a:rPr lang="en-US" dirty="0"/>
               <a:t>RECORDING SCRIPT · minute 1:00
-Here is the map. Segment one, the three drifts: input, prediction, concept. Segment two, the performance metrics: accuracy, precision and recall, AUC, calibration, all from one confusion matrix. Segment three is new this year: ground truth, which is to say, the awkward fact that most performance metrics need to know what really happened, and in production you often do not know, or you know late, or only for some cases. Segment four, three minutes on operational metrics. Segment five, language-model deployments, where there is usually no right answer at all. Segment six, alerts in production: a demo, with real files, of how a monitoring job evaluates rules, decides who to wake up, and sends the message. Segment seven, wrap-up and the quiz.
+Here is the map. Segment one, the three drifts: input, prediction, concept. Segment two, the performance metrics: accuracy, precision and recall, AUC, calibration, all from one confusion matrix. Segment three: ground truth, which is to say, the awkward fact that most performance metrics need to know what really happened, and in production you often do not know, or you know late, or only for some cases. Segment four, three minutes on operational metrics. Segment five, language-model deployments, where there is usually no right answer at all. Segment six, alerts in production: a demo, with real files, of how a monitoring job evaluates rules, decides who to wake up, and sends the message. Segment seven, wrap-up and the quiz.
 Running examples you know: TelcoNova churn and IberBank fraud; plus an internal HR assistant that answers from policy documents for the LLM segment. How to use it: for each metric, write one line: "this metric would catch…, and it needs… to be computed". That second half of the sentence is what segment three is about, and the quiz asks for both.
 [Timing: 1:00–3:00]</a:t>
             </a:r>
@@ -1497,7 +1497,7 @@
               <a:rPr lang="en-US" dirty="0"/>
               <a:t>RECORDING SCRIPT · minute 45:00
 Segment six: alerts in production. We have twenty metrics on the table; a monitoring plan is not twenty charts. It is a short list of rules, and a rule has six parts: the metric; the threshold, a number; the window, how long or how often; the severity, is this an incident that wakes someone at three in the morning, or a trend that goes to a channel; the route, who receives it; and the action, what they do. A rule without a route and an action is a chart, not a control.
-On screen is the file that carries those rules for the TelcoNova churn model: alerts.yaml, eight rules; you have it in the Session 9 demo folder. Read one. drifted-features: the metric is the number of input features whose distribution drifted against the June reference; threshold, more than two of seven; window, weekly, two consecutive weeks; severity, trend; route, the Slack channel and the ML engineer; action, check the extract with the data team, retrain on recent data if confirmed. Now the rule below it: missing-features, more than 5% of customers with tenure missing; severity incident, page the on-call engineer, hold the call list. That is the NorthRetail bug from Session 1, turned into a rule.
+On screen is the file that carries those rules for the TelcoNova churn model: alerts.yaml, eight rules; you have it in the Session 9 demo folder. Read one. drifted-features: the metric is how many of the model's six input features drifted against the June reference; threshold, two or more of the six; window, weekly, two consecutive weeks; severity, trend; route, the Slack channel and the ML engineer; action, check the extract with the data team, retrain on recent data if confirmed. Now the rule below it: missing-features, more than 5% of customers with tenure missing; severity incident, page the on-call engineer, hold the call list. That is the NorthRetail bug from Session 1, turned into a rule.
 Notice the two performance rules: their window says "monthly, when labels arrive". Segment three, written into the file. And notice that the accuracy rule exists twice: overall, and per region and tenure band, with a minimum segment size so a segment of twelve customers cannot page anyone.
 [Timing: 45:00–47:30]</a:t>
             </a:r>
@@ -1589,8 +1589,8 @@
               <a:rPr lang="en-US" dirty="0"/>
               <a:t>RECORDING SCRIPT · minute 47:30
 [Screen recording: terminal in the S09/demo folder. Type "python run_alert_checks.py" and let it run; it takes about ten seconds. Then read the output.]
-This is the monitoring job: run_alert_checks.py, a hundred lines of Python you can read. It loads the June reference and this month's data, scores them with the churn model, runs the Evidently drift and missing-value checks as tests, joins the month's labels, which have arrived, computes accuracy overall and per segment, reads the batch time and the latency log, and evaluates every rule in alerts.yaml. Then it prints this.
-Read it top down. Three passed: missing-features, zero; accuracy-overall, 0.80, above 0.75, so the overall number says the model is fine; batch finished at 05:42. Five fired. drifted-features: three of seven, above two. charges-mean-shift: mean 76.5 against a limit of 70; the pricing change. prediction-drift: 0.116, above 0.10; the model is reacting. And accuracy-segment: one segment below 0.70: North, tenure over three years, 0.65 on 349 customers. The overall rule passed and the segment rule fired: that is Session 7's demo turned into an alert, and it is why the rule exists twice. Last, latency-p95: 659 milliseconds over the last ten minutes, and this one is tagged incident.
+This is the monitoring job: run_alert_checks.py, about a hundred and twenty lines of Python you can read. It loads the June reference and this month's data, scores them with the churn model, runs the Evidently drift and missing-value checks as tests, joins the month's labels, which have arrived, computes accuracy overall and per segment, reads the batch time and the latency log, and evaluates every rule in alerts.yaml. Then it prints this.
+Read it top down. Three passed: missing-features, zero; accuracy-overall, 0.80, above 0.75, so the overall number says the model is fine; batch finished at 05:42. Five fired. drifted-features: two of the six inputs, which is the limit. charges-mean-shift: mean 76.5 against a limit of 70; the pricing change. prediction-drift: 0.116, above 0.10; the model is reacting. And accuracy-segment: one segment below 0.70: North, tenure over three years, 0.65 on 349 customers. The overall rule passed and the segment rule fired: that is Session 7's demo turned into an alert, and it is why the rule exists twice. Last, latency-p95: 659 milliseconds over the last ten minutes, and this one is tagged incident.
 Then the summary line: five fired, one incident, four trends, and the script exits with code 1. That exit code is the whole trick: it is how a scheduler knows something is wrong without understanding any of the metrics. Next slide: who runs it, and who gets told.
 [Timing: 47:30–51:00]</a:t>
             </a:r>
@@ -1682,7 +1682,7 @@
               <a:rPr lang="en-US" dirty="0"/>
               <a:t>RECORDING SCRIPT · minute 51:00
 [Screen recording: open monitoring.yml in the editor; then alert_message.md; then alert_checks.html in the browser, click "Tests".]
-In production nobody types that command. A scheduler runs it: here, a GitHub Actions workflow, because you saw one in Session 5; cron, Airflow or a cloud scheduler do the same job. Read the schedule: every Monday at six, the weekly drift checks; the second of every month at seven, once the labels have arrived, the performance checks; and on demand, when someone wants to look now. Segment three again: the two schedules exist because the truth has its own calendar. Then the steps: fetch this month's data, run the rules, and, only if the job failed, that is, only if the exit code was 1, post the message to the channel. Last step: keep the HTML report as an artefact, so whoever answers the alert has the evidence.
+In production nobody types that command. A scheduler runs it: here, a GitHub Actions workflow, because you saw one in Session 5; cron, Airflow or a cloud scheduler do the same job. Read the schedule: every Monday at six, the weekly drift checks; the second of every month at seven, once the labels have arrived, the performance checks; and on demand, when someone wants to look now. Segment three again: the two schedules exist because the truth has its own calendar. Then the steps: fetch this month's data, run the rules, and, only if the job failed, that is, only if the exit code was 1, post the message to the channel. Last step, which runs whether or not anything fired: keep the HTML report as an artefact, so whoever answers the alert has the evidence.
 The message is the second file: this is what the ML engineer sees on their phone. Five alerts. Each one: the rule name, the actual value against the threshold, the action, and who it went to. The incident is marked differently, because it pages IT rather than posting to a channel. And at the bottom, the three that passed, and links to the report, to the rules file, and to the run. Everything needed to act, nothing that needs interpreting at three in the morning.
 The third file is the report: Evidently's Tests tab, one success and three failures, the same four data checks with their thresholds written on them. This is where the engineer clicks when the message arrives.
 [Timing: 51:00–54:00]</a:t>
@@ -1774,7 +1774,7 @@
             <a:r>
               <a:rPr lang="en-US" dirty="0"/>
               <a:t>RECORDING SCRIPT · minute 54:00
-The rules page a responder; the owner needs one page they look at every Monday and understand in a minute. For the churn model: at the top, health tiles: the batch finished on time, missing features, drifted features, and the dates: last snapshot, last retrain, model version. In the middle, performance by segment on the monthly labels, with the threshold drawn, and look at the right-hand end: October is marked pending, because October's labels have not arrived; the chart does not pretend. Below, the predicted-risk distribution against the reference, the early warning that does not wait, and the business KPI. Not on the page: seven feature histograms; those live one click deeper, for the engineer following an alert.
+The rules page a responder; the owner needs one page they look at every Monday and understand in a minute. For the churn model: at the top, health tiles: the batch finished on time, missing features, drifted features, and the dates: last snapshot, last retrain, model version. In the middle, performance by segment on the monthly labels, with the threshold drawn, and look at the right-hand end: October is marked pending, because October's labels have not arrived; the chart does not pretend. Below, the predicted-risk distribution against the reference, the early warning that does not wait, and the business KPI. Not on the page: six feature histograms; those live one click deeper, for the engineer following an alert.
 The HR assistant's page has the same shape: conversations, thumbs-up rate, escalation rate, cost against budget; judge scores over time with the weekly human sample as dots; hallucination, toxicity and PII rates with their thresholds, some of them zero; tokens and time to first token; and the three versions in the corner.
 And the rule that keeps any of this alive. Every alert is answered by someone within a defined time, and every alert that fires more than once a week without action gets its threshold reviewed or gets deleted. Our demo fired five alerts in one run; if that happens every Monday, by November nobody reads the channel. Five alerts that always mean something beat fifty that sometimes do. End of segment six.
 [Timing: 54:00–56:00]</a:t>
@@ -2507,7 +2507,7 @@
               <a:rPr lang="en-US" dirty="0"/>
               <a:t>RECORDING SCRIPT · minute 15:30
 Accuracy: the share of all decisions that were right, true positives plus true negatives over everything. 140 plus 690 over 1,000: 83%. For balanced problems it is fine.
-Now the fraud model. Ten thousand transactions, forty are fraud. A "model" that blocks nothing is right on 9,960 of 10,000: accuracy 99.6%, zero fraud caught. Accuracy rewards the majority class; when the event is rare it is nearly meaningless. Churn at 20% is borderline; fraud at 0.4% is hopeless. When someone says "99% accurate", your first question is "how rare is the thing it predicts?".
+Now the fraud model. Ten thousand transactions, forty are fraud. A "model" that blocks nothing is right on 9,960 of 10,000: accuracy 99.6%, zero fraud caught. Accuracy rewards the majority class; when the event is rare it is nearly meaningless. Churn at 20% is usable, with care; fraud at 0.4% is hopeless. When someone says "99% accurate", your first question is "how rare is the thing it predicts?".
 [Timing: 15:30–17:00]</a:t>
             </a:r>
             <a:endParaRPr lang="en-US" dirty="0"/>
@@ -11627,7 +11627,7 @@
                 <a:ea typeface="Calibri" pitchFamily="34" charset="-122"/>
                 <a:cs typeface="Calibri" pitchFamily="34" charset="-120"/>
               </a:rPr>
-              <a:t>Churn: 30 days. Credit default: 12 months. October's performance is drawn in December; the model may be wrong for two months while the chart says "no data yet".</a:t>
+              <a:t>Churn: 30 days. Credit default: 12 months. October's churn performance can only be drawn in November; the model may be wrong for a whole month while the chart says "no data yet".</a:t>
             </a:r>
             <a:endParaRPr lang="en-US" sz="950" dirty="0"/>
           </a:p>
@@ -13550,7 +13550,7 @@
                 <a:ea typeface="Calibri" pitchFamily="34" charset="-122"/>
                 <a:cs typeface="Calibri" pitchFamily="34" charset="-120"/>
               </a:rPr>
-              <a:t>None of the five is free. All of them are cheaper than learning in December that the model was wrong in October, or never learning at all.</a:t>
+              <a:t>None of the five is free. All of them are cheaper than learning in November that the model was wrong all October, or never learning at all.</a:t>
             </a:r>
             <a:endParaRPr lang="en-US" sz="1050" dirty="0"/>
           </a:p>
@@ -14739,7 +14739,7 @@
                 <a:ea typeface="Calibri" pitchFamily="34" charset="-122"/>
                 <a:cs typeface="Calibri" pitchFamily="34" charset="-120"/>
               </a:rPr>
-              <a:t>Last snapshot, last retrain, share of features updated this week. NorthRetail: six months on empty features.</a:t>
+              <a:t>Last snapshot, last retrain, share of features updated this week. NorthRetail: four months on empty features.</a:t>
             </a:r>
             <a:endParaRPr lang="en-US" sz="1000" dirty="0"/>
           </a:p>
@@ -23103,7 +23103,7 @@
                           <a:ea typeface="Calibri" pitchFamily="34" charset="-122"/>
                           <a:cs typeface="Calibri" pitchFamily="34" charset="-120"/>
                         </a:rPr>
-                        <a:t>features whose distribution drifted vs June reference</a:t>
+                        <a:t>of the model's 6 inputs, how many drifted vs the June reference</a:t>
                       </a:r>
                       <a:endParaRPr lang="en-US" sz="900" dirty="0">
                         <a:latin typeface="Calibri" charset="0"/>
@@ -23365,7 +23365,7 @@
                           <a:ea typeface="Calibri" pitchFamily="34" charset="-122"/>
                           <a:cs typeface="Calibri" pitchFamily="34" charset="-120"/>
                         </a:rPr>
-                        <a:t>&gt; 2 of 7 features</a:t>
+                        <a:t>2 or more of 6 features</a:t>
                       </a:r>
                       <a:endParaRPr lang="en-US" sz="900" dirty="0">
                         <a:latin typeface="Calibri" charset="0"/>
@@ -24612,7 +24612,7 @@
               </a:rPr>
               <a:t>- id: drifted-features
   metric: features drifted vs reference
-  threshold: "&gt; 2 of 7 features"
+  threshold: "2 or more of 6"
   window: weekly, two consecutive weeks
   severity: trend
   route: "#churn-model-alerts"
@@ -25274,7 +25274,7 @@
                 <a:ea typeface="Calibri" pitchFamily="34" charset="-122"/>
                 <a:cs typeface="Calibri" pitchFamily="34" charset="-120"/>
               </a:rPr>
-              <a:t>What run_alert_checks.py does (100 lines)</a:t>
+              <a:t>What run_alert_checks.py does (about 120 lines)</a:t>
             </a:r>
             <a:endParaRPr lang="en-US" sz="1300" dirty="0"/>
           </a:p>
@@ -26098,7 +26098,8 @@
                 <a:ea typeface="Consolas" pitchFamily="34" charset="-122"/>
                 <a:cs typeface="Consolas" pitchFamily="34" charset="-120"/>
               </a:rPr>
-              <a:t>      - uses: upload-artifact</a:t>
+              <a:t>      - uses: upload-artifact
+        if: always()      # even if it fired</a:t>
             </a:r>
             <a:endParaRPr lang="en-US" sz="700" dirty="0"/>
           </a:p>
@@ -27014,7 +27015,7 @@
                 <a:ea typeface="Calibri" pitchFamily="34" charset="-122"/>
                 <a:cs typeface="Calibri" pitchFamily="34" charset="-120"/>
               </a:rPr>
-              <a:t>3 of 7</a:t>
+              <a:t>2 of 6</a:t>
             </a:r>
             <a:endParaRPr lang="en-US" sz="1500" dirty="0"/>
           </a:p>
@@ -28342,7 +28343,7 @@
                 <a:ea typeface="Calibri" pitchFamily="34" charset="-122"/>
                 <a:cs typeface="Calibri" pitchFamily="34" charset="-120"/>
               </a:rPr>
-              <a:t>The owner's page shows "pending" where the truth has not arrived; it does not draw a flat line. Seven feature histograms live one click deeper, for the responder.</a:t>
+              <a:t>The owner's page shows "pending" where the truth has not arrived; it does not draw a flat line. Six feature histograms live one click deeper, for the responder.</a:t>
             </a:r>
             <a:endParaRPr lang="en-US" sz="1000" dirty="0"/>
           </a:p>
@@ -29455,7 +29456,7 @@
                 <a:ea typeface="Calibri" pitchFamily="34" charset="-122"/>
                 <a:cs typeface="Calibri" pitchFamily="34" charset="-120"/>
               </a:rPr>
-              <a:t>Demo files: 2026-27/S09/demo (alerts.yaml, run_alert_checks.py, monitoring.yml, alert_checks.html). Next: Session 10, Saturday 31 October, LLMOps: we build the assistant we have just learned to monitor.</a:t>
+              <a:t>Demo files on the campus, next to this video (alerts.yaml, run_alert_checks.py, monitoring.yml, alert_checks.html). Next: Session 10, Saturday 31 October, LLMOps: we build the assistant we have just learned to monitor.</a:t>
             </a:r>
             <a:endParaRPr lang="en-US" sz="1050" dirty="0"/>
           </a:p>

</xml_diff>